<commit_message>
released classes 3,4 and 5 solutions
</commit_message>
<xml_diff>
--- a/slides/4_ml-pipeline/lecture4_MLpipeline.pptx
+++ b/slides/4_ml-pipeline/lecture4_MLpipeline.pptx
@@ -5,7 +5,7 @@
     <p:sldMasterId id="2147483702" r:id="rId1"/>
   </p:sldMasterIdLst>
   <p:notesMasterIdLst>
-    <p:notesMasterId r:id="rId14"/>
+    <p:notesMasterId r:id="rId13"/>
   </p:notesMasterIdLst>
   <p:sldIdLst>
     <p:sldId id="256" r:id="rId2"/>
@@ -16,10 +16,9 @@
     <p:sldId id="284" r:id="rId7"/>
     <p:sldId id="285" r:id="rId8"/>
     <p:sldId id="283" r:id="rId9"/>
-    <p:sldId id="282" r:id="rId10"/>
-    <p:sldId id="281" r:id="rId11"/>
-    <p:sldId id="286" r:id="rId12"/>
-    <p:sldId id="280" r:id="rId13"/>
+    <p:sldId id="281" r:id="rId10"/>
+    <p:sldId id="286" r:id="rId11"/>
+    <p:sldId id="280" r:id="rId12"/>
   </p:sldIdLst>
   <p:sldSz cx="12192000" cy="6858000"/>
   <p:notesSz cx="6735763" cy="9866313"/>
@@ -211,7 +210,7 @@
           <a:p>
             <a:fld id="{9357E7CD-833A-4057-A34F-721214C10A5F}" type="datetimeFigureOut">
               <a:rPr lang="fr-FR" smtClean="0"/>
-              <a:t>12/03/2025</a:t>
+              <a:t>25/03/2025</a:t>
             </a:fld>
             <a:endParaRPr lang="fr-FR"/>
           </a:p>
@@ -628,7 +627,7 @@
           <a:p>
             <a:fld id="{F6BF3BD9-BA5A-4CBB-9C78-D323B9124BDA}" type="slidenum">
               <a:rPr lang="fr-FR" smtClean="0"/>
-              <a:t>10</a:t>
+              <a:t>9</a:t>
             </a:fld>
             <a:endParaRPr lang="fr-FR"/>
           </a:p>
@@ -12778,11 +12777,7 @@
           <a:p>
             <a:r>
               <a:rPr lang="fr-FR" sz="2800" dirty="0" smtClean="0"/>
-              <a:t>4- </a:t>
-            </a:r>
-            <a:r>
-              <a:rPr lang="fr-FR" sz="2800" dirty="0" smtClean="0"/>
-              <a:t>Building an End to End ML pipeline</a:t>
+              <a:t>4- Building an End to End ML pipeline</a:t>
             </a:r>
             <a:endParaRPr lang="fr-FR" sz="2800" dirty="0"/>
           </a:p>
@@ -12860,10 +12855,10 @@
           <a:lstStyle/>
           <a:p>
             <a:r>
-              <a:rPr lang="it-IT" dirty="0" smtClean="0"/>
-              <a:t>Continuous Integration (CI) and continuous Deployment / Delivery (CD)</a:t>
-            </a:r>
-            <a:endParaRPr lang="it-IT" dirty="0"/>
+              <a:rPr lang="fr-FR" dirty="0" err="1" smtClean="0"/>
+              <a:t>Resources</a:t>
+            </a:r>
+            <a:endParaRPr lang="fr-FR" dirty="0"/>
           </a:p>
         </p:txBody>
       </p:sp>
@@ -12881,14 +12876,71 @@
         <p:txBody>
           <a:bodyPr/>
           <a:lstStyle/>
+          <a:p>
+            <a:r>
+              <a:rPr lang="fr-FR" dirty="0" err="1">
+                <a:hlinkClick r:id="rId2"/>
+              </a:rPr>
+              <a:t>iusztinpaul</a:t>
+            </a:r>
+            <a:r>
+              <a:rPr lang="fr-FR" dirty="0">
+                <a:hlinkClick r:id="rId2"/>
+              </a:rPr>
+              <a:t>/</a:t>
+            </a:r>
+            <a:r>
+              <a:rPr lang="fr-FR" dirty="0" err="1">
+                <a:hlinkClick r:id="rId2"/>
+              </a:rPr>
+              <a:t>energy-forecasting</a:t>
+            </a:r>
+            <a:r>
+              <a:rPr lang="fr-FR" dirty="0">
+                <a:hlinkClick r:id="rId2"/>
+              </a:rPr>
+              <a:t>: 🌀 𝗧𝗵𝗲 𝗙𝘂𝗹𝗹 𝗦𝘁𝗮𝗰𝗸 𝟳-𝗦𝘁𝗲𝗽𝘀 𝗠𝗟𝗢𝗽𝘀 𝗙𝗿𝗮𝗺𝗲𝘄𝗼𝗿𝗸 | 𝗟𝗲𝗮𝗿𝗻 𝗠𝗟𝗘 &amp; 𝗠𝗟𝗢𝗽𝘀 for free by </a:t>
+            </a:r>
+            <a:r>
+              <a:rPr lang="fr-FR" dirty="0" err="1">
+                <a:hlinkClick r:id="rId2"/>
+              </a:rPr>
+              <a:t>designing</a:t>
+            </a:r>
+            <a:r>
+              <a:rPr lang="fr-FR" dirty="0">
+                <a:hlinkClick r:id="rId2"/>
+              </a:rPr>
+              <a:t>, building and </a:t>
+            </a:r>
+            <a:r>
+              <a:rPr lang="fr-FR" dirty="0" err="1">
+                <a:hlinkClick r:id="rId2"/>
+              </a:rPr>
+              <a:t>deploying</a:t>
+            </a:r>
+            <a:r>
+              <a:rPr lang="fr-FR" dirty="0">
+                <a:hlinkClick r:id="rId2"/>
+              </a:rPr>
+              <a:t> an end-to-end ML batch system ~ 𝘴𝘰𝘶𝘳𝘤𝘦 𝘤𝘰𝘥𝘦 + 2.5 𝘩𝘰𝘶𝘳𝘴 𝘰𝘧 𝘳𝘦𝘢𝘥𝘪𝘯𝘨 &amp; 𝘷𝘪𝘥𝘦𝘰 </a:t>
+            </a:r>
+            <a:r>
+              <a:rPr lang="fr-FR" dirty="0" smtClean="0">
+                <a:hlinkClick r:id="rId2"/>
+              </a:rPr>
+              <a:t>𝘮𝘢𝘵𝘦𝘳𝘪𝘢𝘭𝘴</a:t>
+            </a:r>
+            <a:endParaRPr lang="fr-FR" dirty="0" smtClean="0"/>
+          </a:p>
+          <a:p>
+            <a:endParaRPr lang="fr-FR" dirty="0"/>
+          </a:p>
           <a:p>
             <a:pPr marL="0" indent="0">
               <a:buNone/>
             </a:pPr>
             <a:endParaRPr lang="fr-FR" dirty="0" smtClean="0"/>
-          </a:p>
-          <a:p>
-            <a:endParaRPr lang="fr-FR" dirty="0"/>
           </a:p>
         </p:txBody>
       </p:sp>
@@ -12944,64 +12996,16 @@
           </a:p>
         </p:txBody>
       </p:sp>
-      <p:pic>
-        <p:nvPicPr>
-          <p:cNvPr id="7170" name="Picture 2" descr="terminology - How does continuous integration relate to continuous ..."/>
-          <p:cNvPicPr>
-            <a:picLocks noChangeAspect="1" noChangeArrowheads="1"/>
-          </p:cNvPicPr>
-          <p:nvPr/>
-        </p:nvPicPr>
-        <p:blipFill>
-          <a:blip r:embed="rId3">
-            <a:extLst>
-              <a:ext uri="{28A0092B-C50C-407E-A947-70E740481C1C}">
-                <a14:useLocalDpi xmlns:a14="http://schemas.microsoft.com/office/drawing/2010/main" val="0"/>
-              </a:ext>
-            </a:extLst>
-          </a:blip>
-          <a:srcRect/>
-          <a:stretch>
-            <a:fillRect/>
-          </a:stretch>
-        </p:blipFill>
-        <p:spPr bwMode="auto">
-          <a:xfrm>
-            <a:off x="2293250" y="1452364"/>
-            <a:ext cx="7604691" cy="4337050"/>
-          </a:xfrm>
-          <a:prstGeom prst="rect">
-            <a:avLst/>
-          </a:prstGeom>
-          <a:noFill/>
-          <a:extLst>
-            <a:ext uri="{909E8E84-426E-40DD-AFC4-6F175D3DCCD1}">
-              <a14:hiddenFill xmlns:a14="http://schemas.microsoft.com/office/drawing/2010/main">
-                <a:solidFill>
-                  <a:srgbClr val="FFFFFF"/>
-                </a:solidFill>
-              </a14:hiddenFill>
-            </a:ext>
-          </a:extLst>
-        </p:spPr>
-      </p:pic>
     </p:spTree>
     <p:extLst>
       <p:ext uri="{BB962C8B-B14F-4D97-AF65-F5344CB8AC3E}">
-        <p14:creationId xmlns:p14="http://schemas.microsoft.com/office/powerpoint/2010/main" val="588577317"/>
+        <p14:creationId xmlns:p14="http://schemas.microsoft.com/office/powerpoint/2010/main" val="1700571057"/>
       </p:ext>
     </p:extLst>
   </p:cSld>
   <p:clrMapOvr>
     <a:masterClrMapping/>
   </p:clrMapOvr>
-  <p:timing>
-    <p:tnLst>
-      <p:par>
-        <p:cTn id="1" dur="indefinite" restart="never" nodeType="tmRoot"/>
-      </p:par>
-    </p:tnLst>
-  </p:timing>
 </p:sld>
 </file>
 
@@ -13024,12 +13028,12 @@
       </p:grpSpPr>
       <p:sp>
         <p:nvSpPr>
-          <p:cNvPr id="2" name="Titre 1"/>
-          <p:cNvSpPr>
-            <a:spLocks noGrp="1"/>
-          </p:cNvSpPr>
-          <p:nvPr>
-            <p:ph type="title"/>
+          <p:cNvPr id="2" name="Espace réservé du contenu 1"/>
+          <p:cNvSpPr>
+            <a:spLocks noGrp="1"/>
+          </p:cNvSpPr>
+          <p:nvPr>
+            <p:ph sz="quarter" idx="27"/>
           </p:nvPr>
         </p:nvSpPr>
         <p:spPr/>
@@ -13038,21 +13042,21 @@
           <a:lstStyle/>
           <a:p>
             <a:r>
-              <a:rPr lang="fr-FR" dirty="0" err="1" smtClean="0"/>
-              <a:t>Resources</a:t>
-            </a:r>
-            <a:endParaRPr lang="fr-FR" dirty="0"/>
-          </a:p>
-        </p:txBody>
-      </p:sp>
-      <p:sp>
-        <p:nvSpPr>
-          <p:cNvPr id="3" name="Espace réservé du texte 2"/>
-          <p:cNvSpPr>
-            <a:spLocks noGrp="1"/>
-          </p:cNvSpPr>
-          <p:nvPr>
-            <p:ph type="body" sz="quarter" idx="14"/>
+              <a:rPr lang="fr-FR" sz="2000" b="1" dirty="0" smtClean="0"/>
+              <a:t>Extra</a:t>
+            </a:r>
+            <a:endParaRPr lang="fr-FR" sz="2000" b="1" dirty="0"/>
+          </a:p>
+        </p:txBody>
+      </p:sp>
+      <p:sp>
+        <p:nvSpPr>
+          <p:cNvPr id="3" name="Espace réservé du contenu 2"/>
+          <p:cNvSpPr>
+            <a:spLocks noGrp="1"/>
+          </p:cNvSpPr>
+          <p:nvPr>
+            <p:ph sz="quarter" idx="26"/>
           </p:nvPr>
         </p:nvSpPr>
         <p:spPr/>
@@ -13061,75 +13065,399 @@
           <a:lstStyle/>
           <a:p>
             <a:r>
-              <a:rPr lang="fr-FR" dirty="0" err="1">
-                <a:hlinkClick r:id="rId2"/>
-              </a:rPr>
-              <a:t>iusztinpaul</a:t>
-            </a:r>
-            <a:r>
-              <a:rPr lang="fr-FR" dirty="0">
-                <a:hlinkClick r:id="rId2"/>
-              </a:rPr>
-              <a:t>/</a:t>
-            </a:r>
-            <a:r>
-              <a:rPr lang="fr-FR" dirty="0" err="1">
-                <a:hlinkClick r:id="rId2"/>
-              </a:rPr>
-              <a:t>energy-forecasting</a:t>
-            </a:r>
-            <a:r>
-              <a:rPr lang="fr-FR" dirty="0">
-                <a:hlinkClick r:id="rId2"/>
-              </a:rPr>
-              <a:t>: 🌀 𝗧𝗵𝗲 𝗙𝘂𝗹𝗹 𝗦𝘁𝗮𝗰𝗸 𝟳-𝗦𝘁𝗲𝗽𝘀 𝗠𝗟𝗢𝗽𝘀 𝗙𝗿𝗮𝗺𝗲𝘄𝗼𝗿𝗸 | 𝗟𝗲𝗮𝗿𝗻 𝗠𝗟𝗘 &amp; 𝗠𝗟𝗢𝗽𝘀 for free by </a:t>
-            </a:r>
-            <a:r>
-              <a:rPr lang="fr-FR" dirty="0" err="1">
-                <a:hlinkClick r:id="rId2"/>
-              </a:rPr>
-              <a:t>designing</a:t>
-            </a:r>
-            <a:r>
-              <a:rPr lang="fr-FR" dirty="0">
-                <a:hlinkClick r:id="rId2"/>
-              </a:rPr>
-              <a:t>, building and </a:t>
-            </a:r>
-            <a:r>
-              <a:rPr lang="fr-FR" dirty="0" err="1">
-                <a:hlinkClick r:id="rId2"/>
-              </a:rPr>
-              <a:t>deploying</a:t>
-            </a:r>
-            <a:r>
-              <a:rPr lang="fr-FR" dirty="0">
-                <a:hlinkClick r:id="rId2"/>
-              </a:rPr>
-              <a:t> an end-to-end ML batch system ~ 𝘴𝘰𝘶𝘳𝘤𝘦 𝘤𝘰𝘥𝘦 + 2.5 𝘩𝘰𝘶𝘳𝘴 𝘰𝘧 𝘳𝘦𝘢𝘥𝘪𝘯𝘨 &amp; 𝘷𝘪𝘥𝘦𝘰 </a:t>
-            </a:r>
-            <a:r>
-              <a:rPr lang="fr-FR" dirty="0" smtClean="0">
-                <a:hlinkClick r:id="rId2"/>
-              </a:rPr>
-              <a:t>𝘮𝘢𝘵𝘦𝘳𝘪𝘢𝘭𝘴</a:t>
-            </a:r>
-            <a:endParaRPr lang="fr-FR" dirty="0" smtClean="0"/>
-          </a:p>
-          <a:p>
+              <a:rPr lang="fr-FR" dirty="0" smtClean="0"/>
+              <a:t>2</a:t>
+            </a:r>
             <a:endParaRPr lang="fr-FR" dirty="0"/>
           </a:p>
-          <a:p>
-            <a:pPr marL="0" indent="0">
-              <a:buNone/>
-            </a:pPr>
-            <a:endParaRPr lang="fr-FR" dirty="0" smtClean="0"/>
-          </a:p>
-        </p:txBody>
-      </p:sp>
-      <p:sp>
-        <p:nvSpPr>
-          <p:cNvPr id="4" name="Espace réservé du numéro de diapositive 3"/>
+        </p:txBody>
+      </p:sp>
+      <p:sp>
+        <p:nvSpPr>
+          <p:cNvPr id="4" name="Titre 3"/>
+          <p:cNvSpPr>
+            <a:spLocks noGrp="1"/>
+          </p:cNvSpPr>
+          <p:nvPr>
+            <p:ph type="title"/>
+          </p:nvPr>
+        </p:nvSpPr>
+        <p:spPr/>
+        <p:txBody>
+          <a:bodyPr/>
+          <a:lstStyle/>
+          <a:p>
+            <a:r>
+              <a:rPr lang="fr-FR" dirty="0" err="1" smtClean="0"/>
+              <a:t>Today’s</a:t>
+            </a:r>
+            <a:r>
+              <a:rPr lang="fr-FR" dirty="0" smtClean="0"/>
+              <a:t> objectives</a:t>
+            </a:r>
+            <a:endParaRPr lang="fr-FR" dirty="0"/>
+          </a:p>
+        </p:txBody>
+      </p:sp>
+      <p:sp>
+        <p:nvSpPr>
+          <p:cNvPr id="5" name="Espace réservé du texte 4"/>
+          <p:cNvSpPr>
+            <a:spLocks noGrp="1"/>
+          </p:cNvSpPr>
+          <p:nvPr>
+            <p:ph type="body" sz="quarter" idx="13"/>
+          </p:nvPr>
+        </p:nvSpPr>
+        <p:spPr/>
+        <p:txBody>
+          <a:bodyPr/>
+          <a:lstStyle/>
+          <a:p>
+            <a:r>
+              <a:rPr lang="fr-FR" dirty="0" err="1" smtClean="0"/>
+              <a:t>Implement</a:t>
+            </a:r>
+            <a:r>
+              <a:rPr lang="fr-FR" dirty="0" smtClean="0"/>
+              <a:t> TFX</a:t>
+            </a:r>
+            <a:endParaRPr lang="fr-FR" dirty="0"/>
+          </a:p>
+        </p:txBody>
+      </p:sp>
+      <p:sp>
+        <p:nvSpPr>
+          <p:cNvPr id="6" name="Espace réservé du texte 5"/>
+          <p:cNvSpPr>
+            <a:spLocks noGrp="1"/>
+          </p:cNvSpPr>
+          <p:nvPr>
+            <p:ph type="body" sz="quarter" idx="14"/>
+          </p:nvPr>
+        </p:nvSpPr>
+        <p:spPr/>
+        <p:txBody>
+          <a:bodyPr/>
+          <a:lstStyle/>
+          <a:p>
+            <a:r>
+              <a:rPr lang="fr-FR" dirty="0" err="1" smtClean="0"/>
+              <a:t>Continuous</a:t>
+            </a:r>
+            <a:r>
+              <a:rPr lang="fr-FR" dirty="0" smtClean="0"/>
+              <a:t> training</a:t>
+            </a:r>
+            <a:endParaRPr lang="fr-FR" dirty="0"/>
+          </a:p>
+        </p:txBody>
+      </p:sp>
+      <p:sp>
+        <p:nvSpPr>
+          <p:cNvPr id="7" name="Espace réservé du texte 6"/>
+          <p:cNvSpPr>
+            <a:spLocks noGrp="1"/>
+          </p:cNvSpPr>
+          <p:nvPr>
+            <p:ph type="body" sz="quarter" idx="15"/>
+          </p:nvPr>
+        </p:nvSpPr>
+        <p:spPr/>
+        <p:txBody>
+          <a:bodyPr/>
+          <a:lstStyle/>
+          <a:p>
+            <a:r>
+              <a:rPr lang="fr-FR" dirty="0" err="1" smtClean="0"/>
+              <a:t>Continuous</a:t>
+            </a:r>
+            <a:r>
+              <a:rPr lang="fr-FR" dirty="0" smtClean="0"/>
+              <a:t> </a:t>
+            </a:r>
+            <a:r>
+              <a:rPr lang="fr-FR" dirty="0" err="1" smtClean="0"/>
+              <a:t>Integration</a:t>
+            </a:r>
+            <a:r>
+              <a:rPr lang="fr-FR" dirty="0" smtClean="0"/>
+              <a:t> / </a:t>
+            </a:r>
+            <a:r>
+              <a:rPr lang="fr-FR" dirty="0" err="1" smtClean="0"/>
+              <a:t>Continuous</a:t>
+            </a:r>
+            <a:r>
+              <a:rPr lang="fr-FR" dirty="0" smtClean="0"/>
+              <a:t> </a:t>
+            </a:r>
+            <a:r>
+              <a:rPr lang="fr-FR" dirty="0" err="1" smtClean="0"/>
+              <a:t>Deployment</a:t>
+            </a:r>
+            <a:r>
+              <a:rPr lang="fr-FR" dirty="0" smtClean="0"/>
+              <a:t> (CI/CD)</a:t>
+            </a:r>
+            <a:endParaRPr lang="fr-FR" dirty="0"/>
+          </a:p>
+        </p:txBody>
+      </p:sp>
+      <p:sp>
+        <p:nvSpPr>
+          <p:cNvPr id="8" name="Espace réservé du texte 7"/>
+          <p:cNvSpPr>
+            <a:spLocks noGrp="1"/>
+          </p:cNvSpPr>
+          <p:nvPr>
+            <p:ph type="body" sz="quarter" idx="19"/>
+          </p:nvPr>
+        </p:nvSpPr>
+        <p:spPr/>
+        <p:txBody>
+          <a:bodyPr/>
+          <a:lstStyle/>
+          <a:p>
+            <a:endParaRPr lang="fr-FR" dirty="0"/>
+          </a:p>
+        </p:txBody>
+      </p:sp>
+      <p:sp>
+        <p:nvSpPr>
+          <p:cNvPr id="9" name="Espace réservé du texte 8"/>
+          <p:cNvSpPr>
+            <a:spLocks noGrp="1"/>
+          </p:cNvSpPr>
+          <p:nvPr>
+            <p:ph type="body" sz="quarter" idx="22"/>
+          </p:nvPr>
+        </p:nvSpPr>
+        <p:spPr/>
+        <p:txBody>
+          <a:bodyPr/>
+          <a:lstStyle/>
+          <a:p>
+            <a:endParaRPr lang="fr-FR" dirty="0"/>
+          </a:p>
+        </p:txBody>
+      </p:sp>
+      <p:sp>
+        <p:nvSpPr>
+          <p:cNvPr id="10" name="Espace réservé du texte 9"/>
+          <p:cNvSpPr>
+            <a:spLocks noGrp="1"/>
+          </p:cNvSpPr>
+          <p:nvPr>
+            <p:ph type="body" sz="quarter" idx="23"/>
+          </p:nvPr>
+        </p:nvSpPr>
+        <p:spPr/>
+        <p:txBody>
+          <a:bodyPr/>
+          <a:lstStyle/>
+          <a:p>
+            <a:endParaRPr lang="fr-FR"/>
+          </a:p>
+        </p:txBody>
+      </p:sp>
+      <p:sp>
+        <p:nvSpPr>
+          <p:cNvPr id="11" name="Espace réservé du contenu 10"/>
+          <p:cNvSpPr>
+            <a:spLocks noGrp="1"/>
+          </p:cNvSpPr>
+          <p:nvPr>
+            <p:ph sz="quarter" idx="24"/>
+          </p:nvPr>
+        </p:nvSpPr>
+        <p:spPr/>
+        <p:txBody>
+          <a:bodyPr/>
+          <a:lstStyle/>
+          <a:p>
+            <a:r>
+              <a:rPr lang="fr-FR" dirty="0" smtClean="0"/>
+              <a:t>1</a:t>
+            </a:r>
+            <a:endParaRPr lang="fr-FR" dirty="0"/>
+          </a:p>
+        </p:txBody>
+      </p:sp>
+      <p:sp>
+        <p:nvSpPr>
+          <p:cNvPr id="12" name="Espace réservé du contenu 11"/>
+          <p:cNvSpPr>
+            <a:spLocks noGrp="1"/>
+          </p:cNvSpPr>
+          <p:nvPr>
+            <p:ph sz="quarter" idx="28"/>
+          </p:nvPr>
+        </p:nvSpPr>
+        <p:spPr/>
+        <p:txBody>
+          <a:bodyPr/>
+          <a:lstStyle/>
+          <a:p>
+            <a:endParaRPr lang="fr-FR"/>
+          </a:p>
+        </p:txBody>
+      </p:sp>
+      <p:sp>
+        <p:nvSpPr>
+          <p:cNvPr id="13" name="Espace réservé du contenu 12"/>
+          <p:cNvSpPr>
+            <a:spLocks noGrp="1"/>
+          </p:cNvSpPr>
+          <p:nvPr>
+            <p:ph sz="quarter" idx="29"/>
+          </p:nvPr>
+        </p:nvSpPr>
+        <p:spPr/>
+        <p:txBody>
+          <a:bodyPr/>
+          <a:lstStyle/>
+          <a:p>
+            <a:endParaRPr lang="fr-FR" dirty="0"/>
+          </a:p>
+        </p:txBody>
+      </p:sp>
+      <p:sp>
+        <p:nvSpPr>
+          <p:cNvPr id="14" name="Espace réservé du texte 13"/>
+          <p:cNvSpPr>
+            <a:spLocks noGrp="1"/>
+          </p:cNvSpPr>
+          <p:nvPr>
+            <p:ph type="body" sz="quarter" idx="30"/>
+          </p:nvPr>
+        </p:nvSpPr>
+        <p:spPr/>
+        <p:txBody>
+          <a:bodyPr/>
+          <a:lstStyle/>
+          <a:p>
+            <a:endParaRPr lang="fr-FR" dirty="0"/>
+          </a:p>
+        </p:txBody>
+      </p:sp>
+      <p:sp>
+        <p:nvSpPr>
+          <p:cNvPr id="15" name="Espace réservé du texte 14"/>
+          <p:cNvSpPr>
+            <a:spLocks noGrp="1"/>
+          </p:cNvSpPr>
+          <p:nvPr>
+            <p:ph type="body" sz="quarter" idx="31"/>
+          </p:nvPr>
+        </p:nvSpPr>
+        <p:spPr/>
+        <p:txBody>
+          <a:bodyPr/>
+          <a:lstStyle/>
+          <a:p>
+            <a:endParaRPr lang="fr-FR" dirty="0"/>
+          </a:p>
+        </p:txBody>
+      </p:sp>
+      <p:sp>
+        <p:nvSpPr>
+          <p:cNvPr id="16" name="Espace réservé du texte 15"/>
+          <p:cNvSpPr>
+            <a:spLocks noGrp="1"/>
+          </p:cNvSpPr>
+          <p:nvPr>
+            <p:ph type="body" sz="quarter" idx="32"/>
+          </p:nvPr>
+        </p:nvSpPr>
+        <p:spPr/>
+        <p:txBody>
+          <a:bodyPr/>
+          <a:lstStyle/>
+          <a:p>
+            <a:endParaRPr lang="fr-FR"/>
+          </a:p>
+        </p:txBody>
+      </p:sp>
+      <p:sp>
+        <p:nvSpPr>
+          <p:cNvPr id="17" name="Espace réservé du texte 16"/>
+          <p:cNvSpPr>
+            <a:spLocks noGrp="1"/>
+          </p:cNvSpPr>
+          <p:nvPr>
+            <p:ph type="body" sz="quarter" idx="33"/>
+          </p:nvPr>
+        </p:nvSpPr>
+        <p:spPr/>
+        <p:txBody>
+          <a:bodyPr/>
+          <a:lstStyle/>
+          <a:p>
+            <a:endParaRPr lang="fr-FR"/>
+          </a:p>
+        </p:txBody>
+      </p:sp>
+      <p:sp>
+        <p:nvSpPr>
+          <p:cNvPr id="18" name="Espace réservé du texte 17"/>
+          <p:cNvSpPr>
+            <a:spLocks noGrp="1"/>
+          </p:cNvSpPr>
+          <p:nvPr>
+            <p:ph type="body" sz="quarter" idx="34"/>
+          </p:nvPr>
+        </p:nvSpPr>
+        <p:spPr/>
+        <p:txBody>
+          <a:bodyPr/>
+          <a:lstStyle/>
+          <a:p>
+            <a:endParaRPr lang="fr-FR"/>
+          </a:p>
+        </p:txBody>
+      </p:sp>
+      <p:sp>
+        <p:nvSpPr>
+          <p:cNvPr id="19" name="Espace réservé du texte 18"/>
+          <p:cNvSpPr>
+            <a:spLocks noGrp="1"/>
+          </p:cNvSpPr>
+          <p:nvPr>
+            <p:ph type="body" sz="quarter" idx="35"/>
+          </p:nvPr>
+        </p:nvSpPr>
+        <p:spPr/>
+        <p:txBody>
+          <a:bodyPr/>
+          <a:lstStyle/>
+          <a:p>
+            <a:endParaRPr lang="fr-FR"/>
+          </a:p>
+        </p:txBody>
+      </p:sp>
+      <p:sp>
+        <p:nvSpPr>
+          <p:cNvPr id="20" name="Espace réservé du contenu 19"/>
+          <p:cNvSpPr>
+            <a:spLocks noGrp="1"/>
+          </p:cNvSpPr>
+          <p:nvPr>
+            <p:ph sz="quarter" idx="36"/>
+          </p:nvPr>
+        </p:nvSpPr>
+        <p:spPr/>
+        <p:txBody>
+          <a:bodyPr/>
+          <a:lstStyle/>
+          <a:p>
+            <a:endParaRPr lang="fr-FR" sz="2400" dirty="0"/>
+          </a:p>
+        </p:txBody>
+      </p:sp>
+      <p:sp>
+        <p:nvSpPr>
+          <p:cNvPr id="21" name="Espace réservé du numéro de diapositive 20"/>
           <p:cNvSpPr>
             <a:spLocks noGrp="1"/>
           </p:cNvSpPr>
@@ -13151,517 +13479,6 @@
                 <a:defRPr/>
               </a:pPr>
               <a:t>11</a:t>
-            </a:fld>
-            <a:endParaRPr lang="fr-FR" dirty="0"/>
-          </a:p>
-        </p:txBody>
-      </p:sp>
-      <p:sp>
-        <p:nvSpPr>
-          <p:cNvPr id="5" name="Espace réservé du pied de page 4"/>
-          <p:cNvSpPr>
-            <a:spLocks noGrp="1"/>
-          </p:cNvSpPr>
-          <p:nvPr>
-            <p:ph type="ftr" sz="quarter" idx="3"/>
-          </p:nvPr>
-        </p:nvSpPr>
-        <p:spPr/>
-        <p:txBody>
-          <a:bodyPr/>
-          <a:lstStyle/>
-          <a:p>
-            <a:r>
-              <a:rPr lang="en-US" smtClean="0"/>
-              <a:t>2024 | ©HeadMind Partners</a:t>
-            </a:r>
-            <a:endParaRPr lang="fr-FR" dirty="0"/>
-          </a:p>
-        </p:txBody>
-      </p:sp>
-    </p:spTree>
-    <p:extLst>
-      <p:ext uri="{BB962C8B-B14F-4D97-AF65-F5344CB8AC3E}">
-        <p14:creationId xmlns:p14="http://schemas.microsoft.com/office/powerpoint/2010/main" val="1700571057"/>
-      </p:ext>
-    </p:extLst>
-  </p:cSld>
-  <p:clrMapOvr>
-    <a:masterClrMapping/>
-  </p:clrMapOvr>
-</p:sld>
-</file>
-
-<file path=ppt/slides/slide12.xml><?xml version="1.0" encoding="utf-8"?>
-<p:sld xmlns:a="http://schemas.openxmlformats.org/drawingml/2006/main" xmlns:r="http://schemas.openxmlformats.org/officeDocument/2006/relationships" xmlns:p="http://schemas.openxmlformats.org/presentationml/2006/main">
-  <p:cSld>
-    <p:spTree>
-      <p:nvGrpSpPr>
-        <p:cNvPr id="1" name=""/>
-        <p:cNvGrpSpPr/>
-        <p:nvPr/>
-      </p:nvGrpSpPr>
-      <p:grpSpPr>
-        <a:xfrm>
-          <a:off x="0" y="0"/>
-          <a:ext cx="0" cy="0"/>
-          <a:chOff x="0" y="0"/>
-          <a:chExt cx="0" cy="0"/>
-        </a:xfrm>
-      </p:grpSpPr>
-      <p:sp>
-        <p:nvSpPr>
-          <p:cNvPr id="2" name="Espace réservé du contenu 1"/>
-          <p:cNvSpPr>
-            <a:spLocks noGrp="1"/>
-          </p:cNvSpPr>
-          <p:nvPr>
-            <p:ph sz="quarter" idx="27"/>
-          </p:nvPr>
-        </p:nvSpPr>
-        <p:spPr/>
-        <p:txBody>
-          <a:bodyPr/>
-          <a:lstStyle/>
-          <a:p>
-            <a:r>
-              <a:rPr lang="fr-FR" sz="2000" b="1" dirty="0" smtClean="0"/>
-              <a:t>Extra</a:t>
-            </a:r>
-            <a:endParaRPr lang="fr-FR" sz="2000" b="1" dirty="0"/>
-          </a:p>
-        </p:txBody>
-      </p:sp>
-      <p:sp>
-        <p:nvSpPr>
-          <p:cNvPr id="3" name="Espace réservé du contenu 2"/>
-          <p:cNvSpPr>
-            <a:spLocks noGrp="1"/>
-          </p:cNvSpPr>
-          <p:nvPr>
-            <p:ph sz="quarter" idx="26"/>
-          </p:nvPr>
-        </p:nvSpPr>
-        <p:spPr/>
-        <p:txBody>
-          <a:bodyPr/>
-          <a:lstStyle/>
-          <a:p>
-            <a:r>
-              <a:rPr lang="fr-FR" dirty="0" smtClean="0"/>
-              <a:t>2</a:t>
-            </a:r>
-            <a:endParaRPr lang="fr-FR" dirty="0"/>
-          </a:p>
-        </p:txBody>
-      </p:sp>
-      <p:sp>
-        <p:nvSpPr>
-          <p:cNvPr id="4" name="Titre 3"/>
-          <p:cNvSpPr>
-            <a:spLocks noGrp="1"/>
-          </p:cNvSpPr>
-          <p:nvPr>
-            <p:ph type="title"/>
-          </p:nvPr>
-        </p:nvSpPr>
-        <p:spPr/>
-        <p:txBody>
-          <a:bodyPr/>
-          <a:lstStyle/>
-          <a:p>
-            <a:r>
-              <a:rPr lang="fr-FR" dirty="0" err="1" smtClean="0"/>
-              <a:t>Today’s</a:t>
-            </a:r>
-            <a:r>
-              <a:rPr lang="fr-FR" dirty="0" smtClean="0"/>
-              <a:t> objectives</a:t>
-            </a:r>
-            <a:endParaRPr lang="fr-FR" dirty="0"/>
-          </a:p>
-        </p:txBody>
-      </p:sp>
-      <p:sp>
-        <p:nvSpPr>
-          <p:cNvPr id="5" name="Espace réservé du texte 4"/>
-          <p:cNvSpPr>
-            <a:spLocks noGrp="1"/>
-          </p:cNvSpPr>
-          <p:nvPr>
-            <p:ph type="body" sz="quarter" idx="13"/>
-          </p:nvPr>
-        </p:nvSpPr>
-        <p:spPr/>
-        <p:txBody>
-          <a:bodyPr/>
-          <a:lstStyle/>
-          <a:p>
-            <a:r>
-              <a:rPr lang="fr-FR" dirty="0" err="1" smtClean="0"/>
-              <a:t>Implement</a:t>
-            </a:r>
-            <a:r>
-              <a:rPr lang="fr-FR" dirty="0" smtClean="0"/>
-              <a:t> TFX</a:t>
-            </a:r>
-            <a:endParaRPr lang="fr-FR" dirty="0"/>
-          </a:p>
-        </p:txBody>
-      </p:sp>
-      <p:sp>
-        <p:nvSpPr>
-          <p:cNvPr id="6" name="Espace réservé du texte 5"/>
-          <p:cNvSpPr>
-            <a:spLocks noGrp="1"/>
-          </p:cNvSpPr>
-          <p:nvPr>
-            <p:ph type="body" sz="quarter" idx="14"/>
-          </p:nvPr>
-        </p:nvSpPr>
-        <p:spPr/>
-        <p:txBody>
-          <a:bodyPr/>
-          <a:lstStyle/>
-          <a:p>
-            <a:r>
-              <a:rPr lang="fr-FR" dirty="0" err="1" smtClean="0"/>
-              <a:t>Continuous</a:t>
-            </a:r>
-            <a:r>
-              <a:rPr lang="fr-FR" dirty="0" smtClean="0"/>
-              <a:t> training</a:t>
-            </a:r>
-            <a:endParaRPr lang="fr-FR" dirty="0"/>
-          </a:p>
-        </p:txBody>
-      </p:sp>
-      <p:sp>
-        <p:nvSpPr>
-          <p:cNvPr id="7" name="Espace réservé du texte 6"/>
-          <p:cNvSpPr>
-            <a:spLocks noGrp="1"/>
-          </p:cNvSpPr>
-          <p:nvPr>
-            <p:ph type="body" sz="quarter" idx="15"/>
-          </p:nvPr>
-        </p:nvSpPr>
-        <p:spPr/>
-        <p:txBody>
-          <a:bodyPr/>
-          <a:lstStyle/>
-          <a:p>
-            <a:r>
-              <a:rPr lang="fr-FR" dirty="0" err="1" smtClean="0"/>
-              <a:t>Continuous</a:t>
-            </a:r>
-            <a:r>
-              <a:rPr lang="fr-FR" dirty="0" smtClean="0"/>
-              <a:t> </a:t>
-            </a:r>
-            <a:r>
-              <a:rPr lang="fr-FR" dirty="0" err="1" smtClean="0"/>
-              <a:t>Integration</a:t>
-            </a:r>
-            <a:r>
-              <a:rPr lang="fr-FR" dirty="0" smtClean="0"/>
-              <a:t> / </a:t>
-            </a:r>
-            <a:r>
-              <a:rPr lang="fr-FR" dirty="0" err="1" smtClean="0"/>
-              <a:t>Continuous</a:t>
-            </a:r>
-            <a:r>
-              <a:rPr lang="fr-FR" dirty="0" smtClean="0"/>
-              <a:t> </a:t>
-            </a:r>
-            <a:r>
-              <a:rPr lang="fr-FR" dirty="0" err="1" smtClean="0"/>
-              <a:t>Deployment</a:t>
-            </a:r>
-            <a:r>
-              <a:rPr lang="fr-FR" dirty="0" smtClean="0"/>
-              <a:t> (CI/CD)</a:t>
-            </a:r>
-            <a:endParaRPr lang="fr-FR" dirty="0"/>
-          </a:p>
-        </p:txBody>
-      </p:sp>
-      <p:sp>
-        <p:nvSpPr>
-          <p:cNvPr id="8" name="Espace réservé du texte 7"/>
-          <p:cNvSpPr>
-            <a:spLocks noGrp="1"/>
-          </p:cNvSpPr>
-          <p:nvPr>
-            <p:ph type="body" sz="quarter" idx="19"/>
-          </p:nvPr>
-        </p:nvSpPr>
-        <p:spPr/>
-        <p:txBody>
-          <a:bodyPr/>
-          <a:lstStyle/>
-          <a:p>
-            <a:endParaRPr lang="fr-FR" dirty="0"/>
-          </a:p>
-        </p:txBody>
-      </p:sp>
-      <p:sp>
-        <p:nvSpPr>
-          <p:cNvPr id="9" name="Espace réservé du texte 8"/>
-          <p:cNvSpPr>
-            <a:spLocks noGrp="1"/>
-          </p:cNvSpPr>
-          <p:nvPr>
-            <p:ph type="body" sz="quarter" idx="22"/>
-          </p:nvPr>
-        </p:nvSpPr>
-        <p:spPr/>
-        <p:txBody>
-          <a:bodyPr/>
-          <a:lstStyle/>
-          <a:p>
-            <a:endParaRPr lang="fr-FR" dirty="0"/>
-          </a:p>
-        </p:txBody>
-      </p:sp>
-      <p:sp>
-        <p:nvSpPr>
-          <p:cNvPr id="10" name="Espace réservé du texte 9"/>
-          <p:cNvSpPr>
-            <a:spLocks noGrp="1"/>
-          </p:cNvSpPr>
-          <p:nvPr>
-            <p:ph type="body" sz="quarter" idx="23"/>
-          </p:nvPr>
-        </p:nvSpPr>
-        <p:spPr/>
-        <p:txBody>
-          <a:bodyPr/>
-          <a:lstStyle/>
-          <a:p>
-            <a:endParaRPr lang="fr-FR"/>
-          </a:p>
-        </p:txBody>
-      </p:sp>
-      <p:sp>
-        <p:nvSpPr>
-          <p:cNvPr id="11" name="Espace réservé du contenu 10"/>
-          <p:cNvSpPr>
-            <a:spLocks noGrp="1"/>
-          </p:cNvSpPr>
-          <p:nvPr>
-            <p:ph sz="quarter" idx="24"/>
-          </p:nvPr>
-        </p:nvSpPr>
-        <p:spPr/>
-        <p:txBody>
-          <a:bodyPr/>
-          <a:lstStyle/>
-          <a:p>
-            <a:r>
-              <a:rPr lang="fr-FR" dirty="0" smtClean="0"/>
-              <a:t>1</a:t>
-            </a:r>
-            <a:endParaRPr lang="fr-FR" dirty="0"/>
-          </a:p>
-        </p:txBody>
-      </p:sp>
-      <p:sp>
-        <p:nvSpPr>
-          <p:cNvPr id="12" name="Espace réservé du contenu 11"/>
-          <p:cNvSpPr>
-            <a:spLocks noGrp="1"/>
-          </p:cNvSpPr>
-          <p:nvPr>
-            <p:ph sz="quarter" idx="28"/>
-          </p:nvPr>
-        </p:nvSpPr>
-        <p:spPr/>
-        <p:txBody>
-          <a:bodyPr/>
-          <a:lstStyle/>
-          <a:p>
-            <a:endParaRPr lang="fr-FR"/>
-          </a:p>
-        </p:txBody>
-      </p:sp>
-      <p:sp>
-        <p:nvSpPr>
-          <p:cNvPr id="13" name="Espace réservé du contenu 12"/>
-          <p:cNvSpPr>
-            <a:spLocks noGrp="1"/>
-          </p:cNvSpPr>
-          <p:nvPr>
-            <p:ph sz="quarter" idx="29"/>
-          </p:nvPr>
-        </p:nvSpPr>
-        <p:spPr/>
-        <p:txBody>
-          <a:bodyPr/>
-          <a:lstStyle/>
-          <a:p>
-            <a:endParaRPr lang="fr-FR" dirty="0"/>
-          </a:p>
-        </p:txBody>
-      </p:sp>
-      <p:sp>
-        <p:nvSpPr>
-          <p:cNvPr id="14" name="Espace réservé du texte 13"/>
-          <p:cNvSpPr>
-            <a:spLocks noGrp="1"/>
-          </p:cNvSpPr>
-          <p:nvPr>
-            <p:ph type="body" sz="quarter" idx="30"/>
-          </p:nvPr>
-        </p:nvSpPr>
-        <p:spPr/>
-        <p:txBody>
-          <a:bodyPr/>
-          <a:lstStyle/>
-          <a:p>
-            <a:endParaRPr lang="fr-FR" dirty="0"/>
-          </a:p>
-        </p:txBody>
-      </p:sp>
-      <p:sp>
-        <p:nvSpPr>
-          <p:cNvPr id="15" name="Espace réservé du texte 14"/>
-          <p:cNvSpPr>
-            <a:spLocks noGrp="1"/>
-          </p:cNvSpPr>
-          <p:nvPr>
-            <p:ph type="body" sz="quarter" idx="31"/>
-          </p:nvPr>
-        </p:nvSpPr>
-        <p:spPr/>
-        <p:txBody>
-          <a:bodyPr/>
-          <a:lstStyle/>
-          <a:p>
-            <a:endParaRPr lang="fr-FR" dirty="0"/>
-          </a:p>
-        </p:txBody>
-      </p:sp>
-      <p:sp>
-        <p:nvSpPr>
-          <p:cNvPr id="16" name="Espace réservé du texte 15"/>
-          <p:cNvSpPr>
-            <a:spLocks noGrp="1"/>
-          </p:cNvSpPr>
-          <p:nvPr>
-            <p:ph type="body" sz="quarter" idx="32"/>
-          </p:nvPr>
-        </p:nvSpPr>
-        <p:spPr/>
-        <p:txBody>
-          <a:bodyPr/>
-          <a:lstStyle/>
-          <a:p>
-            <a:endParaRPr lang="fr-FR"/>
-          </a:p>
-        </p:txBody>
-      </p:sp>
-      <p:sp>
-        <p:nvSpPr>
-          <p:cNvPr id="17" name="Espace réservé du texte 16"/>
-          <p:cNvSpPr>
-            <a:spLocks noGrp="1"/>
-          </p:cNvSpPr>
-          <p:nvPr>
-            <p:ph type="body" sz="quarter" idx="33"/>
-          </p:nvPr>
-        </p:nvSpPr>
-        <p:spPr/>
-        <p:txBody>
-          <a:bodyPr/>
-          <a:lstStyle/>
-          <a:p>
-            <a:endParaRPr lang="fr-FR"/>
-          </a:p>
-        </p:txBody>
-      </p:sp>
-      <p:sp>
-        <p:nvSpPr>
-          <p:cNvPr id="18" name="Espace réservé du texte 17"/>
-          <p:cNvSpPr>
-            <a:spLocks noGrp="1"/>
-          </p:cNvSpPr>
-          <p:nvPr>
-            <p:ph type="body" sz="quarter" idx="34"/>
-          </p:nvPr>
-        </p:nvSpPr>
-        <p:spPr/>
-        <p:txBody>
-          <a:bodyPr/>
-          <a:lstStyle/>
-          <a:p>
-            <a:endParaRPr lang="fr-FR"/>
-          </a:p>
-        </p:txBody>
-      </p:sp>
-      <p:sp>
-        <p:nvSpPr>
-          <p:cNvPr id="19" name="Espace réservé du texte 18"/>
-          <p:cNvSpPr>
-            <a:spLocks noGrp="1"/>
-          </p:cNvSpPr>
-          <p:nvPr>
-            <p:ph type="body" sz="quarter" idx="35"/>
-          </p:nvPr>
-        </p:nvSpPr>
-        <p:spPr/>
-        <p:txBody>
-          <a:bodyPr/>
-          <a:lstStyle/>
-          <a:p>
-            <a:endParaRPr lang="fr-FR"/>
-          </a:p>
-        </p:txBody>
-      </p:sp>
-      <p:sp>
-        <p:nvSpPr>
-          <p:cNvPr id="20" name="Espace réservé du contenu 19"/>
-          <p:cNvSpPr>
-            <a:spLocks noGrp="1"/>
-          </p:cNvSpPr>
-          <p:nvPr>
-            <p:ph sz="quarter" idx="36"/>
-          </p:nvPr>
-        </p:nvSpPr>
-        <p:spPr/>
-        <p:txBody>
-          <a:bodyPr/>
-          <a:lstStyle/>
-          <a:p>
-            <a:endParaRPr lang="fr-FR" sz="2400" dirty="0"/>
-          </a:p>
-        </p:txBody>
-      </p:sp>
-      <p:sp>
-        <p:nvSpPr>
-          <p:cNvPr id="21" name="Espace réservé du numéro de diapositive 20"/>
-          <p:cNvSpPr>
-            <a:spLocks noGrp="1"/>
-          </p:cNvSpPr>
-          <p:nvPr>
-            <p:ph type="sldNum" sz="quarter" idx="4"/>
-          </p:nvPr>
-        </p:nvSpPr>
-        <p:spPr/>
-        <p:txBody>
-          <a:bodyPr/>
-          <a:lstStyle/>
-          <a:p>
-            <a:pPr>
-              <a:defRPr/>
-            </a:pPr>
-            <a:fld id="{F4FEB08F-923E-484A-9FC5-0AA7BDA29BD6}" type="slidenum">
-              <a:rPr lang="fr-FR" smtClean="0"/>
-              <a:pPr>
-                <a:defRPr/>
-              </a:pPr>
-              <a:t>12</a:t>
             </a:fld>
             <a:endParaRPr lang="fr-FR" dirty="0"/>
           </a:p>
@@ -13796,7 +13613,6 @@
               <a:rPr lang="fr-FR" dirty="0"/>
               <a:t> a ML pipeline</a:t>
             </a:r>
-            <a:endParaRPr lang="fr-FR" dirty="0"/>
           </a:p>
         </p:txBody>
       </p:sp>
@@ -13844,11 +13660,7 @@
             </a:r>
             <a:r>
               <a:rPr lang="en-US" dirty="0" smtClean="0"/>
-              <a:t>in order to serve a </a:t>
-            </a:r>
-            <a:r>
-              <a:rPr lang="en-US" dirty="0" smtClean="0"/>
-              <a:t>machine </a:t>
+              <a:t>in order to serve a machine </a:t>
             </a:r>
             <a:r>
               <a:rPr lang="en-US" dirty="0"/>
@@ -13877,15 +13689,7 @@
                   <a:srgbClr val="00B050"/>
                 </a:solidFill>
               </a:rPr>
-              <a:t>In green the concepts seen in classes #</a:t>
-            </a:r>
-            <a:r>
-              <a:rPr lang="en-US" b="1" dirty="0" smtClean="0">
-                <a:solidFill>
-                  <a:srgbClr val="00B050"/>
-                </a:solidFill>
-              </a:rPr>
-              <a:t>1-2-3 /5</a:t>
+              <a:t>In green the concepts seen in classes #1-2-3 /5</a:t>
             </a:r>
           </a:p>
           <a:p>
@@ -14912,11 +14716,7 @@
             </a:r>
             <a:r>
               <a:rPr lang="en-US" dirty="0" smtClean="0"/>
-              <a:t>at </a:t>
-            </a:r>
-            <a:r>
-              <a:rPr lang="en-US" dirty="0" smtClean="0"/>
-              <a:t>Spotify</a:t>
+              <a:t>at Spotify</a:t>
             </a:r>
             <a:r>
               <a:rPr lang="en-US" dirty="0"/>
@@ -16227,18 +16027,10 @@
           <a:lstStyle/>
           <a:p>
             <a:r>
-              <a:rPr lang="fr-FR" dirty="0" err="1" smtClean="0"/>
-              <a:t>Concrete</a:t>
-            </a:r>
-            <a:r>
-              <a:rPr lang="fr-FR" dirty="0" smtClean="0"/>
-              <a:t> </a:t>
-            </a:r>
-            <a:r>
-              <a:rPr lang="fr-FR" dirty="0" err="1" smtClean="0"/>
-              <a:t>example</a:t>
-            </a:r>
-            <a:endParaRPr lang="fr-FR" dirty="0"/>
+              <a:rPr lang="it-IT" dirty="0" smtClean="0"/>
+              <a:t>Continuous Integration (CI) and continuous Deployment / Delivery (CD)</a:t>
+            </a:r>
+            <a:endParaRPr lang="it-IT" dirty="0"/>
           </a:p>
         </p:txBody>
       </p:sp>
@@ -16256,23 +16048,6 @@
         <p:txBody>
           <a:bodyPr/>
           <a:lstStyle/>
-          <a:p>
-            <a:pPr marL="0" indent="0">
-              <a:buNone/>
-            </a:pPr>
-            <a:r>
-              <a:rPr lang="fr-FR" dirty="0" smtClean="0"/>
-              <a:t>Inférence flux de trésorerie intra-</a:t>
-            </a:r>
-            <a:r>
-              <a:rPr lang="fr-FR" dirty="0" err="1" smtClean="0"/>
-              <a:t>day</a:t>
-            </a:r>
-            <a:r>
-              <a:rPr lang="fr-FR" dirty="0" smtClean="0"/>
-              <a:t> Société Générale</a:t>
-            </a:r>
-          </a:p>
           <a:p>
             <a:pPr marL="0" indent="0">
               <a:buNone/>
@@ -16280,29 +16055,7 @@
             <a:endParaRPr lang="fr-FR" dirty="0" smtClean="0"/>
           </a:p>
           <a:p>
-            <a:pPr marL="0" indent="0">
-              <a:buNone/>
-            </a:pPr>
-            <a:r>
-              <a:rPr lang="fr-FR" dirty="0" err="1" smtClean="0"/>
-              <a:t>XGBoost</a:t>
-            </a:r>
             <a:endParaRPr lang="fr-FR" dirty="0"/>
-          </a:p>
-          <a:p>
-            <a:pPr marL="0" indent="0">
-              <a:buNone/>
-            </a:pPr>
-            <a:r>
-              <a:rPr lang="fr-FR" dirty="0" smtClean="0"/>
-              <a:t>Neural network</a:t>
-            </a:r>
-          </a:p>
-          <a:p>
-            <a:pPr marL="0" indent="0">
-              <a:buNone/>
-            </a:pPr>
-            <a:endParaRPr lang="fr-FR" dirty="0" smtClean="0"/>
           </a:p>
         </p:txBody>
       </p:sp>
@@ -16358,71 +16111,64 @@
           </a:p>
         </p:txBody>
       </p:sp>
-      <p:sp>
-        <p:nvSpPr>
-          <p:cNvPr id="6" name="Rectangle 5"/>
-          <p:cNvSpPr/>
+      <p:pic>
+        <p:nvPicPr>
+          <p:cNvPr id="7170" name="Picture 2" descr="terminology - How does continuous integration relate to continuous ..."/>
+          <p:cNvPicPr>
+            <a:picLocks noChangeAspect="1" noChangeArrowheads="1"/>
+          </p:cNvPicPr>
           <p:nvPr/>
-        </p:nvSpPr>
-        <p:spPr>
-          <a:xfrm>
-            <a:off x="8304824" y="23243"/>
-            <a:ext cx="2464776" cy="1193800"/>
+        </p:nvPicPr>
+        <p:blipFill>
+          <a:blip r:embed="rId3">
+            <a:extLst>
+              <a:ext uri="{28A0092B-C50C-407E-A947-70E740481C1C}">
+                <a14:useLocalDpi xmlns:a14="http://schemas.microsoft.com/office/drawing/2010/main" val="0"/>
+              </a:ext>
+            </a:extLst>
+          </a:blip>
+          <a:srcRect/>
+          <a:stretch>
+            <a:fillRect/>
+          </a:stretch>
+        </p:blipFill>
+        <p:spPr bwMode="auto">
+          <a:xfrm>
+            <a:off x="2293250" y="1452364"/>
+            <a:ext cx="7604691" cy="4337050"/>
           </a:xfrm>
           <a:prstGeom prst="rect">
             <a:avLst/>
           </a:prstGeom>
-          <a:solidFill>
-            <a:srgbClr val="FFFF00"/>
-          </a:solidFill>
-        </p:spPr>
-        <p:style>
-          <a:lnRef idx="2">
-            <a:schemeClr val="accent1">
-              <a:shade val="50000"/>
-            </a:schemeClr>
-          </a:lnRef>
-          <a:fillRef idx="1">
-            <a:schemeClr val="accent1"/>
-          </a:fillRef>
-          <a:effectRef idx="0">
-            <a:schemeClr val="accent1"/>
-          </a:effectRef>
-          <a:fontRef idx="minor">
-            <a:schemeClr val="lt1"/>
-          </a:fontRef>
-        </p:style>
-        <p:txBody>
-          <a:bodyPr rtlCol="0" anchor="ctr"/>
-          <a:lstStyle/>
-          <a:p>
-            <a:pPr algn="ctr"/>
-            <a:r>
-              <a:rPr lang="fr-FR" dirty="0" smtClean="0">
-                <a:solidFill>
-                  <a:srgbClr val="FF0000"/>
-                </a:solidFill>
-              </a:rPr>
-              <a:t>TODO</a:t>
-            </a:r>
-            <a:endParaRPr lang="fr-FR" dirty="0">
-              <a:solidFill>
-                <a:srgbClr val="FF0000"/>
-              </a:solidFill>
-            </a:endParaRPr>
-          </a:p>
-        </p:txBody>
-      </p:sp>
+          <a:noFill/>
+          <a:extLst>
+            <a:ext uri="{909E8E84-426E-40DD-AFC4-6F175D3DCCD1}">
+              <a14:hiddenFill xmlns:a14="http://schemas.microsoft.com/office/drawing/2010/main">
+                <a:solidFill>
+                  <a:srgbClr val="FFFFFF"/>
+                </a:solidFill>
+              </a14:hiddenFill>
+            </a:ext>
+          </a:extLst>
+        </p:spPr>
+      </p:pic>
     </p:spTree>
     <p:extLst>
       <p:ext uri="{BB962C8B-B14F-4D97-AF65-F5344CB8AC3E}">
-        <p14:creationId xmlns:p14="http://schemas.microsoft.com/office/powerpoint/2010/main" val="2769200393"/>
+        <p14:creationId xmlns:p14="http://schemas.microsoft.com/office/powerpoint/2010/main" val="588577317"/>
       </p:ext>
     </p:extLst>
   </p:cSld>
   <p:clrMapOvr>
     <a:masterClrMapping/>
   </p:clrMapOvr>
+  <p:timing>
+    <p:tnLst>
+      <p:par>
+        <p:cTn id="1" dur="indefinite" restart="never" nodeType="tmRoot"/>
+      </p:par>
+    </p:tnLst>
+  </p:timing>
 </p:sld>
 </file>
 

</xml_diff>